<commit_message>
feature impelementation reskin deck, bulk download, font fix
</commit_message>
<xml_diff>
--- a/data/templates/case_study_v2.pptx
+++ b/data/templates/case_study_v2.pptx
@@ -3832,7 +3832,7 @@
                 <a:solidFill>
                   <a:srgbClr val="111110"/>
                 </a:solidFill>
-                <a:latin typeface="Helvetica"/>
+                <a:latin typeface="Raleway"/>
               </a:rPr>
               <a:t>The Challenge</a:t>
             </a:r>
@@ -3867,7 +3867,7 @@
                 <a:solidFill>
                   <a:srgbClr val="3E3E3E"/>
                 </a:solidFill>
-                <a:latin typeface="Helvetica"/>
+                <a:latin typeface="Raleway"/>
               </a:rPr>
               <a:t>{{CHALLENGE}}</a:t>
             </a:r>
@@ -3990,7 +3990,7 @@
                 <a:solidFill>
                   <a:srgbClr val="111110"/>
                 </a:solidFill>
-                <a:latin typeface="Helvetica"/>
+                <a:latin typeface="Raleway"/>
               </a:rPr>
               <a:t>The Solution</a:t>
             </a:r>
@@ -4025,7 +4025,7 @@
                 <a:solidFill>
                   <a:srgbClr val="3E3E3E"/>
                 </a:solidFill>
-                <a:latin typeface="Helvetica"/>
+                <a:latin typeface="Raleway"/>
               </a:rPr>
               <a:t>{{SOLUTION}}</a:t>
             </a:r>
@@ -4060,7 +4060,7 @@
                 <a:solidFill>
                   <a:srgbClr val="3A8B82"/>
                 </a:solidFill>
-                <a:latin typeface="Helvetica"/>
+                <a:latin typeface="Raleway"/>
               </a:rPr>
               <a:t>Key Capabilities Developed</a:t>
             </a:r>
@@ -4140,7 +4140,7 @@
                 <a:solidFill>
                   <a:srgbClr val="111110"/>
                 </a:solidFill>
-                <a:latin typeface="Helvetica"/>
+                <a:latin typeface="Raleway"/>
               </a:rPr>
               <a:t>{{CAP_1_TITLE}}</a:t>
             </a:r>
@@ -4175,7 +4175,7 @@
                 <a:solidFill>
                   <a:srgbClr val="3E3E3E"/>
                 </a:solidFill>
-                <a:latin typeface="Helvetica"/>
+                <a:latin typeface="Raleway"/>
               </a:rPr>
               <a:t>{{CAP_1_BODY}}</a:t>
             </a:r>
@@ -4255,7 +4255,7 @@
                 <a:solidFill>
                   <a:srgbClr val="111110"/>
                 </a:solidFill>
-                <a:latin typeface="Helvetica"/>
+                <a:latin typeface="Raleway"/>
               </a:rPr>
               <a:t>{{CAP_2_TITLE}}</a:t>
             </a:r>
@@ -4290,7 +4290,7 @@
                 <a:solidFill>
                   <a:srgbClr val="3E3E3E"/>
                 </a:solidFill>
-                <a:latin typeface="Helvetica"/>
+                <a:latin typeface="Raleway"/>
               </a:rPr>
               <a:t>{{CAP_2_BODY}}</a:t>
             </a:r>
@@ -4370,7 +4370,7 @@
                 <a:solidFill>
                   <a:srgbClr val="111110"/>
                 </a:solidFill>
-                <a:latin typeface="Helvetica"/>
+                <a:latin typeface="Raleway"/>
               </a:rPr>
               <a:t>{{CAP_3_TITLE}}</a:t>
             </a:r>
@@ -4405,7 +4405,7 @@
                 <a:solidFill>
                   <a:srgbClr val="3E3E3E"/>
                 </a:solidFill>
-                <a:latin typeface="Helvetica"/>
+                <a:latin typeface="Raleway"/>
               </a:rPr>
               <a:t>{{CAP_3_BODY}}</a:t>
             </a:r>
@@ -4485,7 +4485,7 @@
                 <a:solidFill>
                   <a:srgbClr val="111110"/>
                 </a:solidFill>
-                <a:latin typeface="Helvetica"/>
+                <a:latin typeface="Raleway"/>
               </a:rPr>
               <a:t>{{CAP_4_TITLE}}</a:t>
             </a:r>
@@ -4520,7 +4520,7 @@
                 <a:solidFill>
                   <a:srgbClr val="3E3E3E"/>
                 </a:solidFill>
-                <a:latin typeface="Helvetica"/>
+                <a:latin typeface="Raleway"/>
               </a:rPr>
               <a:t>{{CAP_4_BODY}}</a:t>
             </a:r>
@@ -4600,7 +4600,7 @@
                 <a:solidFill>
                   <a:srgbClr val="111110"/>
                 </a:solidFill>
-                <a:latin typeface="Helvetica"/>
+                <a:latin typeface="Raleway"/>
               </a:rPr>
               <a:t>{{CAP_5_TITLE}}</a:t>
             </a:r>
@@ -4635,7 +4635,7 @@
                 <a:solidFill>
                   <a:srgbClr val="3E3E3E"/>
                 </a:solidFill>
-                <a:latin typeface="Helvetica"/>
+                <a:latin typeface="Raleway"/>
               </a:rPr>
               <a:t>{{CAP_5_BODY}}</a:t>
             </a:r>
@@ -4715,7 +4715,7 @@
                 <a:solidFill>
                   <a:srgbClr val="111110"/>
                 </a:solidFill>
-                <a:latin typeface="Helvetica"/>
+                <a:latin typeface="Raleway"/>
               </a:rPr>
               <a:t>{{CAP_6_TITLE}}</a:t>
             </a:r>
@@ -4750,7 +4750,7 @@
                 <a:solidFill>
                   <a:srgbClr val="3E3E3E"/>
                 </a:solidFill>
-                <a:latin typeface="Helvetica"/>
+                <a:latin typeface="Raleway"/>
               </a:rPr>
               <a:t>{{CAP_6_BODY}}</a:t>
             </a:r>
@@ -4828,7 +4828,7 @@
                 <a:solidFill>
                   <a:srgbClr val="FFFFFF"/>
                 </a:solidFill>
-                <a:latin typeface="Helvetica"/>
+                <a:latin typeface="Raleway"/>
               </a:rPr>
               <a:t>{{RESULT_1_PCT}}</a:t>
             </a:r>
@@ -4863,7 +4863,7 @@
                 <a:solidFill>
                   <a:srgbClr val="FFFFFF"/>
                 </a:solidFill>
-                <a:latin typeface="Helvetica"/>
+                <a:latin typeface="Raleway"/>
               </a:rPr>
               <a:t>{{RESULT_1_TEXT}}</a:t>
             </a:r>
@@ -4898,7 +4898,7 @@
                 <a:solidFill>
                   <a:srgbClr val="FFFFFF"/>
                 </a:solidFill>
-                <a:latin typeface="Helvetica"/>
+                <a:latin typeface="Raleway"/>
               </a:rPr>
               <a:t>{{RESULT_2_PCT}}</a:t>
             </a:r>
@@ -4933,7 +4933,7 @@
                 <a:solidFill>
                   <a:srgbClr val="FFFFFF"/>
                 </a:solidFill>
-                <a:latin typeface="Helvetica"/>
+                <a:latin typeface="Raleway"/>
               </a:rPr>
               <a:t>{{RESULT_2_TEXT}}</a:t>
             </a:r>
@@ -4968,7 +4968,7 @@
                 <a:solidFill>
                   <a:srgbClr val="FFFFFF"/>
                 </a:solidFill>
-                <a:latin typeface="Helvetica"/>
+                <a:latin typeface="Raleway"/>
               </a:rPr>
               <a:t>{{RESULT_3_PCT}}</a:t>
             </a:r>
@@ -5003,7 +5003,7 @@
                 <a:solidFill>
                   <a:srgbClr val="FFFFFF"/>
                 </a:solidFill>
-                <a:latin typeface="Helvetica"/>
+                <a:latin typeface="Raleway"/>
               </a:rPr>
               <a:t>{{RESULT_3_TEXT}}</a:t>
             </a:r>

</xml_diff>